<commit_message>
Deck: rupee glyph in the PDF, fresh Requests snapshot; handoff and README point at the review report and deck
Co-Authored-By: Claude Fable 5.1 <noreply@anthropic.com>
</commit_message>
<xml_diff>
--- a/submission/Collab-AI-Builder-Cup.pptx
+++ b/submission/Collab-AI-Builder-Cup.pptx
@@ -8270,7 +8270,7 @@
         <p:spPr>
           <a:xfrm>
             <a:off x="4617720" y="1234440"/>
-            <a:ext cx="2500312" cy="1600200"/>
+            <a:ext cx="4023360" cy="1207008"/>
           </a:xfrm>
           <a:prstGeom prst="rect">
             <a:avLst/>
@@ -8285,7 +8285,7 @@
         </p:nvSpPr>
         <p:spPr>
           <a:xfrm>
-            <a:off x="4617720" y="2852928"/>
+            <a:off x="4617720" y="2459736"/>
             <a:ext cx="4023360" cy="228600"/>
           </a:xfrm>
           <a:prstGeom prst="rect">

</xml_diff>

<commit_message>
Deck and report: 108 tests
Co-Authored-By: Claude Fable 5.1 <noreply@anthropic.com>
</commit_message>
<xml_diff>
--- a/submission/Collab-AI-Builder-Cup.pptx
+++ b/submission/Collab-AI-Builder-Cup.pptx
@@ -9509,7 +9509,7 @@
                 </a:solidFill>
                 <a:latin typeface="Arial"/>
               </a:rPr>
-              <a:t>104 / 104</a:t>
+              <a:t>108 / 108</a:t>
             </a:r>
           </a:p>
         </p:txBody>
@@ -13465,7 +13465,7 @@
                 </a:solidFill>
                 <a:latin typeface="Arial"/>
               </a:rPr>
-              <a:t>104 unit/e2e tests; benchmark harness; Vertex AI evaluation autorater</a:t>
+              <a:t>108 unit/e2e tests; benchmark harness; Vertex AI evaluation autorater</a:t>
             </a:r>
           </a:p>
         </p:txBody>

</xml_diff>